<commit_message>
Bring in Field-to-Market upstream through d4cab3b
Applies upstream commits 3f6e5a9, 199350f, e8211c4 and d4cab3b
(per-pixel armor imagery, METHODS citations, NDVI-DFI unmixing
sources, cover crop thresholds). Resolved fieldrs/__init__.py by
keeping both the catalog/climate exports and the new armor exports.

Co-Authored-By: Claude Opus 5.5 <noreply@anthropic.com>
</commit_message>
<xml_diff>
--- a/pitch/cotton-2026/Cotton-Remote-Sensing-Pitch.pptx
+++ b/pitch/cotton-2026/Cotton-Remote-Sensing-Pitch.pptx
@@ -6860,7 +6860,7 @@
                 </a:solidFill>
                 <a:latin typeface="Arial"/>
               </a:rPr>
-              <a:t>Our cover crop threshold was set from Corn Belt literature, where winter residue sits at NDVI 0.10–0.25. In Georgia the median field with no cover crop at all peaks at 0.53 — 0.50 on cotton. Winter weeds, volunteer and a mild climate put green on ground nobody planted.</a:t>
+              <a:t>Our cover crop threshold came from Mid-Atlantic literature, where winter residue sits at NDVI 0.10–0.25. In Georgia the median field with no cover crop at all peaks at 0.53 — 0.50 on cotton. Winter weeds, volunteer and a mild climate put green on ground nobody planted.</a:t>
             </a:r>
           </a:p>
         </p:txBody>
@@ -6947,7 +6947,7 @@
                 </a:solidFill>
                 <a:latin typeface="Arial Narrow"/>
               </a:rPr>
-              <a:t>CORN BELT THRESHOLD</a:t>
+              <a:t>OUT-OF-REGION THRESHOLD</a:t>
             </a:r>
           </a:p>
         </p:txBody>
@@ -8949,7 +8949,7 @@
                           </a:solidFill>
                           <a:latin typeface="Arial"/>
                         </a:rPr>
-                        <a:t>A Corn Belt number cost us 60 false alarms on 68 fields</a:t>
+                        <a:t>An out-of-region number cost us 60 false alarms on 68 fields</a:t>
                       </a:r>
                     </a:p>
                   </a:txBody>

</xml_diff>